<commit_message>
Add security posture slide and update customer traction table
</commit_message>
<xml_diff>
--- a/GPU_Optimizer_ventureLAB_Deck.pptx
+++ b/GPU_Optimizer_ventureLAB_Deck.pptx
@@ -13,6 +13,7 @@
     <p:sldId id="261" r:id="rId7"/>
     <p:sldId id="262" r:id="rId8"/>
     <p:sldId id="263" r:id="rId9"/>
+    <p:sldId id="264" r:id="rId15"/>
   </p:sldIdLst>
   <p:notesMasterIdLst>
     <p:notesMasterId r:id="rId10"/>
@@ -4973,6 +4974,138 @@
                   </a:tcPr>
                 </a:tc>
               </a:tr>
+              <a:tr h="594360">
+                <a:tc>
+                  <a:txBody>
+                    <a:bodyPr/>
+                    <a:lstStyle/>
+                    <a:p>
+                      <a:pPr indent="0" marL="0">
+                        <a:buNone/>
+                      </a:pPr>
+                      <a:r>
+                        <a:rPr lang="en-US" sz="1200" dirty="0">
+                          <a:solidFill>
+                            <a:srgbClr val="000000"/>
+                          </a:solidFill>
+                          <a:latin typeface="Calibri" pitchFamily="34" charset="0"/>
+                          <a:ea typeface="Calibri" pitchFamily="34" charset="-122"/>
+                          <a:cs typeface="Calibri" pitchFamily="34" charset="-120"/>
+                        </a:rPr>
+                        <a:t>Security infrastructure hardened: dependency scanning, branch protection, and audit logging live across all repos</a:t>
+                      </a:r>
+                      <a:endParaRPr lang="en-US" sz="1200" dirty="0">
+                        <a:latin typeface="Calibri" charset="0"/>
+                        <a:ea typeface="Calibri" charset="0"/>
+                        <a:cs typeface="Calibri" charset="0"/>
+                      </a:endParaRPr>
+                    </a:p>
+                  </a:txBody>
+                  <a:tcPr marL="91440" marR="91440" marT="45720" marB="45720" anchor="t">
+                    <a:lnL w="6350" cap="flat" cmpd="sng" algn="ctr">
+                      <a:solidFill>
+                        <a:srgbClr val="DDDDDD"/>
+                      </a:solidFill>
+                      <a:prstDash val="solid"/>
+                      <a:round/>
+                      <a:headEnd type="none" w="med" len="med"/>
+                      <a:tailEnd type="none" w="med" len="med"/>
+                    </a:lnL>
+                    <a:lnR w="6350" cap="flat" cmpd="sng" algn="ctr">
+                      <a:solidFill>
+                        <a:srgbClr val="DDDDDD"/>
+                      </a:solidFill>
+                      <a:prstDash val="solid"/>
+                      <a:round/>
+                      <a:headEnd type="none" w="med" len="med"/>
+                      <a:tailEnd type="none" w="med" len="med"/>
+                    </a:lnR>
+                    <a:lnT w="6350" cap="flat" cmpd="sng" algn="ctr">
+                      <a:solidFill>
+                        <a:srgbClr val="DDDDDD"/>
+                      </a:solidFill>
+                      <a:prstDash val="solid"/>
+                      <a:round/>
+                      <a:headEnd type="none" w="med" len="med"/>
+                      <a:tailEnd type="none" w="med" len="med"/>
+                    </a:lnT>
+                    <a:lnB w="6350" cap="flat" cmpd="sng" algn="ctr">
+                      <a:solidFill>
+                        <a:srgbClr val="DDDDDD"/>
+                      </a:solidFill>
+                      <a:prstDash val="solid"/>
+                      <a:round/>
+                      <a:headEnd type="none" w="med" len="med"/>
+                      <a:tailEnd type="none" w="med" len="med"/>
+                    </a:lnB>
+                  </a:tcPr>
+                </a:tc>
+                <a:tc>
+                  <a:txBody>
+                    <a:bodyPr/>
+                    <a:lstStyle/>
+                    <a:p>
+                      <a:pPr indent="0" marL="0">
+                        <a:buNone/>
+                      </a:pPr>
+                      <a:r>
+                        <a:rPr lang="en-US" sz="1200" dirty="0">
+                          <a:solidFill>
+                            <a:srgbClr val="000000"/>
+                          </a:solidFill>
+                          <a:latin typeface="Calibri" pitchFamily="34" charset="0"/>
+                          <a:ea typeface="Calibri" pitchFamily="34" charset="-122"/>
+                          <a:cs typeface="Calibri" pitchFamily="34" charset="-120"/>
+                        </a:rPr>
+                        <a:t/>
+                      </a:r>
+                      <a:endParaRPr lang="en-US" sz="1200" dirty="0">
+                        <a:latin typeface="Calibri" charset="0"/>
+                        <a:ea typeface="Calibri" charset="0"/>
+                        <a:cs typeface="Calibri" charset="0"/>
+                      </a:endParaRPr>
+                    </a:p>
+                  </a:txBody>
+                  <a:tcPr marL="91440" marR="91440" marT="45720" marB="45720" anchor="t">
+                    <a:lnL w="6350" cap="flat" cmpd="sng" algn="ctr">
+                      <a:solidFill>
+                        <a:srgbClr val="DDDDDD"/>
+                      </a:solidFill>
+                      <a:prstDash val="solid"/>
+                      <a:round/>
+                      <a:headEnd type="none" w="med" len="med"/>
+                      <a:tailEnd type="none" w="med" len="med"/>
+                    </a:lnL>
+                    <a:lnR w="6350" cap="flat" cmpd="sng" algn="ctr">
+                      <a:solidFill>
+                        <a:srgbClr val="DDDDDD"/>
+                      </a:solidFill>
+                      <a:prstDash val="solid"/>
+                      <a:round/>
+                      <a:headEnd type="none" w="med" len="med"/>
+                      <a:tailEnd type="none" w="med" len="med"/>
+                    </a:lnR>
+                    <a:lnT w="6350" cap="flat" cmpd="sng" algn="ctr">
+                      <a:solidFill>
+                        <a:srgbClr val="DDDDDD"/>
+                      </a:solidFill>
+                      <a:prstDash val="solid"/>
+                      <a:round/>
+                      <a:headEnd type="none" w="med" len="med"/>
+                      <a:tailEnd type="none" w="med" len="med"/>
+                    </a:lnT>
+                    <a:lnB w="6350" cap="flat" cmpd="sng" algn="ctr">
+                      <a:solidFill>
+                        <a:srgbClr val="DDDDDD"/>
+                      </a:solidFill>
+                      <a:prstDash val="solid"/>
+                      <a:round/>
+                      <a:headEnd type="none" w="med" len="med"/>
+                      <a:tailEnd type="none" w="med" len="med"/>
+                    </a:lnB>
+                  </a:tcPr>
+                </a:tc>
+              </a:tr>
             </a:tbl>
           </a:graphicData>
         </a:graphic>
@@ -5610,6 +5743,851 @@
           </a:p>
         </p:txBody>
       </p:sp>
+    </p:spTree>
+  </p:cSld>
+  <p:clrMapOvr>
+    <a:masterClrMapping/>
+  </p:clrMapOvr>
+</p:sld>
+</file>
+
+<file path=ppt/slides/slide9.xml><?xml version="1.0" encoding="utf-8"?>
+<p:sld xmlns:a="http://schemas.openxmlformats.org/drawingml/2006/main" xmlns:r="http://schemas.openxmlformats.org/officeDocument/2006/relationships" xmlns:p="http://schemas.openxmlformats.org/presentationml/2006/main">
+  <p:cSld name="Slide 7">
+    <p:bg>
+      <p:bgPr>
+        <a:solidFill>
+          <a:srgbClr val="FFFFFF"/>
+        </a:solidFill>
+      </p:bgPr>
+    </p:bg>
+    <p:spTree>
+      <p:nvGrpSpPr>
+        <p:cNvPr id="1" name=""/>
+        <p:cNvGrpSpPr/>
+        <p:nvPr/>
+      </p:nvGrpSpPr>
+      <p:grpSpPr>
+        <a:xfrm>
+          <a:off x="0" y="0"/>
+          <a:ext cx="0" cy="0"/>
+          <a:chOff x="0" y="0"/>
+          <a:chExt cx="0" cy="0"/>
+        </a:xfrm>
+      </p:grpSpPr>
+      <p:sp>
+        <p:nvSpPr>
+          <p:cNvPr id="2" name="Text 0"/>
+          <p:cNvSpPr/>
+          <p:nvPr/>
+        </p:nvSpPr>
+        <p:spPr>
+          <a:xfrm>
+            <a:off x="548640" y="365760"/>
+            <a:ext cx="9144000" cy="320040"/>
+          </a:xfrm>
+          <a:prstGeom prst="rect">
+            <a:avLst/>
+          </a:prstGeom>
+          <a:noFill/>
+          <a:ln/>
+        </p:spPr>
+        <p:txBody>
+          <a:bodyPr wrap="square" rtlCol="0" anchor="ctr"/>
+          <a:lstStyle/>
+          <a:p>
+            <a:pPr indent="0" marL="0">
+              <a:buNone/>
+            </a:pPr>
+            <a:r>
+              <a:rPr lang="en-US" sz="1100" b="1" spc="200" kern="0" dirty="0">
+                <a:solidFill>
+                  <a:srgbClr val="1E2761"/>
+                </a:solidFill>
+                <a:latin typeface="Calibri" pitchFamily="34" charset="0"/>
+                <a:ea typeface="Calibri" pitchFamily="34" charset="-122"/>
+                <a:cs typeface="Calibri" pitchFamily="34" charset="-120"/>
+              </a:rPr>
+              <a:t>APPENDIX</a:t>
+            </a:r>
+            <a:endParaRPr lang="en-US" sz="1100" dirty="0"/>
+          </a:p>
+        </p:txBody>
+      </p:sp>
+      <p:sp>
+        <p:nvSpPr>
+          <p:cNvPr id="3" name="Text 1"/>
+          <p:cNvSpPr/>
+          <p:nvPr/>
+        </p:nvSpPr>
+        <p:spPr>
+          <a:xfrm>
+            <a:off x="548640" y="685800"/>
+            <a:ext cx="10789920" cy="731520"/>
+          </a:xfrm>
+          <a:prstGeom prst="rect">
+            <a:avLst/>
+          </a:prstGeom>
+          <a:noFill/>
+          <a:ln/>
+        </p:spPr>
+        <p:txBody>
+          <a:bodyPr wrap="square" rtlCol="0" anchor="ctr"/>
+          <a:lstStyle/>
+          <a:p>
+            <a:pPr indent="0" marL="0">
+              <a:buNone/>
+            </a:pPr>
+            <a:r>
+              <a:rPr lang="en-US" sz="2600" b="1" dirty="0">
+                <a:solidFill>
+                  <a:srgbClr val="1E1E2E"/>
+                </a:solidFill>
+                <a:latin typeface="Cambria" pitchFamily="34" charset="0"/>
+                <a:ea typeface="Cambria" pitchFamily="34" charset="-122"/>
+                <a:cs typeface="Cambria" pitchFamily="34" charset="-120"/>
+              </a:rPr>
+              <a:t>Security Posture as of 2026-07-09</a:t>
+            </a:r>
+            <a:endParaRPr lang="en-US" sz="2600" dirty="0"/>
+          </a:p>
+        </p:txBody>
+      </p:sp>
+      <p:sp>
+        <p:nvSpPr>
+          <p:cNvPr id="4" name="Text 2"/>
+          <p:cNvSpPr/>
+          <p:nvPr/>
+        </p:nvSpPr>
+        <p:spPr>
+          <a:xfrm>
+            <a:off x="548640" y="1463040"/>
+            <a:ext cx="10789920" cy="457200"/>
+          </a:xfrm>
+          <a:prstGeom prst="rect">
+            <a:avLst/>
+          </a:prstGeom>
+          <a:noFill/>
+          <a:ln/>
+        </p:spPr>
+        <p:txBody>
+          <a:bodyPr wrap="square" rtlCol="0" anchor="ctr"/>
+          <a:lstStyle/>
+          <a:p>
+            <a:pPr indent="0" marL="0">
+              <a:buNone/>
+            </a:pPr>
+            <a:r>
+              <a:rPr lang="en-US" sz="1450" b="1" dirty="0">
+                <a:solidFill>
+                  <a:srgbClr val="1E1E2E"/>
+                </a:solidFill>
+                <a:latin typeface="Calibri" pitchFamily="34" charset="0"/>
+                <a:ea typeface="Calibri" pitchFamily="34" charset="-122"/>
+                <a:cs typeface="Calibri" pitchFamily="34" charset="-120"/>
+              </a:rPr>
+              <a:t>We de-risked the #1 reason enterprise deals die in procurement: security questionnaires.</a:t>
+            </a:r>
+            <a:endParaRPr lang="en-US" sz="1450" dirty="0"/>
+          </a:p>
+        </p:txBody>
+      </p:sp>
+      <p:graphicFrame>
+        <p:nvGraphicFramePr>
+          <p:cNvPr id="8" name="Table 0"/>
+          <p:cNvGraphicFramePr>
+            <a:graphicFrameLocks noGrp="1"/>
+          </p:cNvGraphicFramePr>
+          <p:nvPr>
+            <p:extLst>
+              <p:ext uri="{D42A27DB-BD31-4B8C-83A1-F6EECF244321}">
+                <p14:modId xmlns:p14="http://schemas.microsoft.com/office/powerpoint/2010/main" val="1579011935"/>
+              </p:ext>
+            </p:extLst>
+          </p:nvPr>
+        </p:nvGraphicFramePr>
+        <p:xfrm>
+          <a:off x="548640" y="2011680"/>
+          <a:ext cx="10789920" cy="2377440"/>
+        </p:xfrm>
+        <a:graphic>
+          <a:graphicData uri="http://schemas.openxmlformats.org/drawingml/2006/table">
+            <a:tbl>
+              <a:tblPr/>
+              <a:tblGrid>
+                <a:gridCol w="5394960"/>
+                <a:gridCol w="5394960"/>
+              </a:tblGrid>
+              <a:tr h="594360">
+                <a:tc>
+                  <a:txBody>
+                    <a:bodyPr/>
+                    <a:lstStyle/>
+                    <a:p>
+                      <a:pPr indent="0" marL="0">
+                        <a:buNone/>
+                      </a:pPr>
+                      <a:r>
+                        <a:rPr lang="en-US" sz="1200" b="1" dirty="0">
+                          <a:solidFill>
+                            <a:srgbClr val="FFFFFF"/>
+                          </a:solidFill>
+                          <a:latin typeface="Calibri" pitchFamily="34" charset="0"/>
+                          <a:ea typeface="Calibri" pitchFamily="34" charset="-122"/>
+                          <a:cs typeface="Calibri" pitchFamily="34" charset="-120"/>
+                        </a:rPr>
+                        <a:t>Technical Controls</a:t>
+                      </a:r>
+                      <a:endParaRPr lang="en-US" sz="1200" dirty="0">
+                        <a:latin typeface="Calibri" charset="0"/>
+                        <a:ea typeface="Calibri" charset="0"/>
+                        <a:cs typeface="Calibri" charset="0"/>
+                      </a:endParaRPr>
+                    </a:p>
+                  </a:txBody>
+                  <a:tcPr marL="91440" marR="91440" marT="45720" marB="45720" anchor="t">
+                    <a:lnL w="6350" cap="flat" cmpd="sng" algn="ctr">
+                      <a:solidFill>
+                        <a:srgbClr val="DDDDDD"/>
+                      </a:solidFill>
+                      <a:prstDash val="solid"/>
+                      <a:round/>
+                      <a:headEnd type="none" w="med" len="med"/>
+                      <a:tailEnd type="none" w="med" len="med"/>
+                    </a:lnL>
+                    <a:lnR w="6350" cap="flat" cmpd="sng" algn="ctr">
+                      <a:solidFill>
+                        <a:srgbClr val="DDDDDD"/>
+                      </a:solidFill>
+                      <a:prstDash val="solid"/>
+                      <a:round/>
+                      <a:headEnd type="none" w="med" len="med"/>
+                      <a:tailEnd type="none" w="med" len="med"/>
+                    </a:lnR>
+                    <a:lnT w="6350" cap="flat" cmpd="sng" algn="ctr">
+                      <a:solidFill>
+                        <a:srgbClr val="DDDDDD"/>
+                      </a:solidFill>
+                      <a:prstDash val="solid"/>
+                      <a:round/>
+                      <a:headEnd type="none" w="med" len="med"/>
+                      <a:tailEnd type="none" w="med" len="med"/>
+                    </a:lnT>
+                    <a:lnB w="6350" cap="flat" cmpd="sng" algn="ctr">
+                      <a:solidFill>
+                        <a:srgbClr val="DDDDDD"/>
+                      </a:solidFill>
+                      <a:prstDash val="solid"/>
+                      <a:round/>
+                      <a:headEnd type="none" w="med" len="med"/>
+                      <a:tailEnd type="none" w="med" len="med"/>
+                    </a:lnB>
+                    <a:solidFill>
+                      <a:srgbClr val="1F9D55"/>
+                    </a:solidFill>
+                  </a:tcPr>
+                </a:tc>
+                <a:tc>
+                  <a:txBody>
+                    <a:bodyPr/>
+                    <a:lstStyle/>
+                    <a:p>
+                      <a:pPr indent="0" marL="0">
+                        <a:buNone/>
+                      </a:pPr>
+                      <a:r>
+                        <a:rPr lang="en-US" sz="1200" b="1" dirty="0">
+                          <a:solidFill>
+                            <a:srgbClr val="FFFFFF"/>
+                          </a:solidFill>
+                          <a:latin typeface="Calibri" pitchFamily="34" charset="0"/>
+                          <a:ea typeface="Calibri" pitchFamily="34" charset="-122"/>
+                          <a:cs typeface="Calibri" pitchFamily="34" charset="-120"/>
+                        </a:rPr>
+                        <a:t>Status</a:t>
+                      </a:r>
+                      <a:endParaRPr lang="en-US" sz="1200" dirty="0">
+                        <a:latin typeface="Calibri" charset="0"/>
+                        <a:ea typeface="Calibri" charset="0"/>
+                        <a:cs typeface="Calibri" charset="0"/>
+                      </a:endParaRPr>
+                    </a:p>
+                  </a:txBody>
+                  <a:tcPr marL="91440" marR="91440" marT="45720" marB="45720" anchor="t">
+                    <a:lnL w="6350" cap="flat" cmpd="sng" algn="ctr">
+                      <a:solidFill>
+                        <a:srgbClr val="DDDDDD"/>
+                      </a:solidFill>
+                      <a:prstDash val="solid"/>
+                      <a:round/>
+                      <a:headEnd type="none" w="med" len="med"/>
+                      <a:tailEnd type="none" w="med" len="med"/>
+                    </a:lnL>
+                    <a:lnR w="6350" cap="flat" cmpd="sng" algn="ctr">
+                      <a:solidFill>
+                        <a:srgbClr val="DDDDDD"/>
+                      </a:solidFill>
+                      <a:prstDash val="solid"/>
+                      <a:round/>
+                      <a:headEnd type="none" w="med" len="med"/>
+                      <a:tailEnd type="none" w="med" len="med"/>
+                    </a:lnR>
+                    <a:lnT w="6350" cap="flat" cmpd="sng" algn="ctr">
+                      <a:solidFill>
+                        <a:srgbClr val="DDDDDD"/>
+                      </a:solidFill>
+                      <a:prstDash val="solid"/>
+                      <a:round/>
+                      <a:headEnd type="none" w="med" len="med"/>
+                      <a:tailEnd type="none" w="med" len="med"/>
+                    </a:lnT>
+                    <a:lnB w="6350" cap="flat" cmpd="sng" algn="ctr">
+                      <a:solidFill>
+                        <a:srgbClr val="DDDDDD"/>
+                      </a:solidFill>
+                      <a:prstDash val="solid"/>
+                      <a:round/>
+                      <a:headEnd type="none" w="med" len="med"/>
+                      <a:tailEnd type="none" w="med" len="med"/>
+                    </a:lnB>
+                    <a:solidFill>
+                      <a:srgbClr val="8A8A8A"/>
+                    </a:solidFill>
+                  </a:tcPr>
+                </a:tc>
+              </a:tr>
+              <a:tr h="594360">
+                <a:tc>
+                  <a:txBody>
+                    <a:bodyPr/>
+                    <a:lstStyle/>
+                    <a:p>
+                      <a:pPr indent="0" marL="0">
+                        <a:buNone/>
+                      </a:pPr>
+                      <a:r>
+                        <a:rPr lang="en-US" sz="1200" dirty="0">
+                          <a:solidFill>
+                            <a:srgbClr val="000000"/>
+                          </a:solidFill>
+                          <a:latin typeface="Calibri" pitchFamily="34" charset="0"/>
+                          <a:ea typeface="Calibri" pitchFamily="34" charset="-122"/>
+                          <a:cs typeface="Calibri" pitchFamily="34" charset="-120"/>
+                        </a:rPr>
+                        <a:t>0 known CVEs (patched CVE-2025-69223, CVSS 7.5, aiohttp zip-bomb DoS, among others)</a:t>
+                      </a:r>
+                      <a:endParaRPr lang="en-US" sz="1200" dirty="0">
+                        <a:latin typeface="Calibri" charset="0"/>
+                        <a:ea typeface="Calibri" charset="0"/>
+                        <a:cs typeface="Calibri" charset="0"/>
+                      </a:endParaRPr>
+                    </a:p>
+                  </a:txBody>
+                  <a:tcPr marL="91440" marR="91440" marT="45720" marB="45720" anchor="t">
+                    <a:lnL w="6350" cap="flat" cmpd="sng" algn="ctr">
+                      <a:solidFill>
+                        <a:srgbClr val="DDDDDD"/>
+                      </a:solidFill>
+                      <a:prstDash val="solid"/>
+                      <a:round/>
+                      <a:headEnd type="none" w="med" len="med"/>
+                      <a:tailEnd type="none" w="med" len="med"/>
+                    </a:lnL>
+                    <a:lnR w="6350" cap="flat" cmpd="sng" algn="ctr">
+                      <a:solidFill>
+                        <a:srgbClr val="DDDDDD"/>
+                      </a:solidFill>
+                      <a:prstDash val="solid"/>
+                      <a:round/>
+                      <a:headEnd type="none" w="med" len="med"/>
+                      <a:tailEnd type="none" w="med" len="med"/>
+                    </a:lnR>
+                    <a:lnT w="6350" cap="flat" cmpd="sng" algn="ctr">
+                      <a:solidFill>
+                        <a:srgbClr val="DDDDDD"/>
+                      </a:solidFill>
+                      <a:prstDash val="solid"/>
+                      <a:round/>
+                      <a:headEnd type="none" w="med" len="med"/>
+                      <a:tailEnd type="none" w="med" len="med"/>
+                    </a:lnT>
+                    <a:lnB w="6350" cap="flat" cmpd="sng" algn="ctr">
+                      <a:solidFill>
+                        <a:srgbClr val="DDDDDD"/>
+                      </a:solidFill>
+                      <a:prstDash val="solid"/>
+                      <a:round/>
+                      <a:headEnd type="none" w="med" len="med"/>
+                      <a:tailEnd type="none" w="med" len="med"/>
+                    </a:lnB>
+                  </a:tcPr>
+                </a:tc>
+                <a:tc>
+                  <a:txBody>
+                    <a:bodyPr/>
+                    <a:lstStyle/>
+                    <a:p>
+                      <a:pPr indent="0" marL="0">
+                        <a:buNone/>
+                      </a:pPr>
+                      <a:r>
+                        <a:rPr lang="en-US" sz="1200" dirty="0">
+                          <a:solidFill>
+                            <a:srgbClr val="000000"/>
+                          </a:solidFill>
+                          <a:latin typeface="Calibri" pitchFamily="34" charset="0"/>
+                          <a:ea typeface="Calibri" pitchFamily="34" charset="-122"/>
+                          <a:cs typeface="Calibri" pitchFamily="34" charset="-120"/>
+                        </a:rPr>
+                        <a:t>Complete</a:t>
+                      </a:r>
+                      <a:endParaRPr lang="en-US" sz="1200" dirty="0">
+                        <a:latin typeface="Calibri" charset="0"/>
+                        <a:ea typeface="Calibri" charset="0"/>
+                        <a:cs typeface="Calibri" charset="0"/>
+                      </a:endParaRPr>
+                    </a:p>
+                  </a:txBody>
+                  <a:tcPr marL="91440" marR="91440" marT="45720" marB="45720" anchor="t">
+                    <a:lnL w="6350" cap="flat" cmpd="sng" algn="ctr">
+                      <a:solidFill>
+                        <a:srgbClr val="DDDDDD"/>
+                      </a:solidFill>
+                      <a:prstDash val="solid"/>
+                      <a:round/>
+                      <a:headEnd type="none" w="med" len="med"/>
+                      <a:tailEnd type="none" w="med" len="med"/>
+                    </a:lnL>
+                    <a:lnR w="6350" cap="flat" cmpd="sng" algn="ctr">
+                      <a:solidFill>
+                        <a:srgbClr val="DDDDDD"/>
+                      </a:solidFill>
+                      <a:prstDash val="solid"/>
+                      <a:round/>
+                      <a:headEnd type="none" w="med" len="med"/>
+                      <a:tailEnd type="none" w="med" len="med"/>
+                    </a:lnR>
+                    <a:lnT w="6350" cap="flat" cmpd="sng" algn="ctr">
+                      <a:solidFill>
+                        <a:srgbClr val="DDDDDD"/>
+                      </a:solidFill>
+                      <a:prstDash val="solid"/>
+                      <a:round/>
+                      <a:headEnd type="none" w="med" len="med"/>
+                      <a:tailEnd type="none" w="med" len="med"/>
+                    </a:lnT>
+                    <a:lnB w="6350" cap="flat" cmpd="sng" algn="ctr">
+                      <a:solidFill>
+                        <a:srgbClr val="DDDDDD"/>
+                      </a:solidFill>
+                      <a:prstDash val="solid"/>
+                      <a:round/>
+                      <a:headEnd type="none" w="med" len="med"/>
+                      <a:tailEnd type="none" w="med" len="med"/>
+                    </a:lnB>
+                  </a:tcPr>
+                </a:tc>
+              </a:tr>
+              <a:tr h="594360">
+                <a:tc>
+                  <a:txBody>
+                    <a:bodyPr/>
+                    <a:lstStyle/>
+                    <a:p>
+                      <a:pPr indent="0" marL="0">
+                        <a:buNone/>
+                      </a:pPr>
+                      <a:r>
+                        <a:rPr lang="en-US" sz="1200" dirty="0">
+                          <a:solidFill>
+                            <a:srgbClr val="000000"/>
+                          </a:solidFill>
+                          <a:latin typeface="Calibri" pitchFamily="34" charset="0"/>
+                          <a:ea typeface="Calibri" pitchFamily="34" charset="-122"/>
+                          <a:cs typeface="Calibri" pitchFamily="34" charset="-120"/>
+                        </a:rPr>
+                        <a:t>Branch protection enforced: PR required, force-push blocked, deletion blocked</a:t>
+                      </a:r>
+                      <a:endParaRPr lang="en-US" sz="1200" dirty="0">
+                        <a:latin typeface="Calibri" charset="0"/>
+                        <a:ea typeface="Calibri" charset="0"/>
+                        <a:cs typeface="Calibri" charset="0"/>
+                      </a:endParaRPr>
+                    </a:p>
+                  </a:txBody>
+                  <a:tcPr marL="91440" marR="91440" marT="45720" marB="45720" anchor="t">
+                    <a:lnL w="6350" cap="flat" cmpd="sng" algn="ctr">
+                      <a:solidFill>
+                        <a:srgbClr val="DDDDDD"/>
+                      </a:solidFill>
+                      <a:prstDash val="solid"/>
+                      <a:round/>
+                      <a:headEnd type="none" w="med" len="med"/>
+                      <a:tailEnd type="none" w="med" len="med"/>
+                    </a:lnL>
+                    <a:lnR w="6350" cap="flat" cmpd="sng" algn="ctr">
+                      <a:solidFill>
+                        <a:srgbClr val="DDDDDD"/>
+                      </a:solidFill>
+                      <a:prstDash val="solid"/>
+                      <a:round/>
+                      <a:headEnd type="none" w="med" len="med"/>
+                      <a:tailEnd type="none" w="med" len="med"/>
+                    </a:lnR>
+                    <a:lnT w="6350" cap="flat" cmpd="sng" algn="ctr">
+                      <a:solidFill>
+                        <a:srgbClr val="DDDDDD"/>
+                      </a:solidFill>
+                      <a:prstDash val="solid"/>
+                      <a:round/>
+                      <a:headEnd type="none" w="med" len="med"/>
+                      <a:tailEnd type="none" w="med" len="med"/>
+                    </a:lnT>
+                    <a:lnB w="6350" cap="flat" cmpd="sng" algn="ctr">
+                      <a:solidFill>
+                        <a:srgbClr val="DDDDDD"/>
+                      </a:solidFill>
+                      <a:prstDash val="solid"/>
+                      <a:round/>
+                      <a:headEnd type="none" w="med" len="med"/>
+                      <a:tailEnd type="none" w="med" len="med"/>
+                    </a:lnB>
+                  </a:tcPr>
+                </a:tc>
+                <a:tc>
+                  <a:txBody>
+                    <a:bodyPr/>
+                    <a:lstStyle/>
+                    <a:p>
+                      <a:pPr indent="0" marL="0">
+                        <a:buNone/>
+                      </a:pPr>
+                      <a:r>
+                        <a:rPr lang="en-US" sz="1200" dirty="0">
+                          <a:solidFill>
+                            <a:srgbClr val="000000"/>
+                          </a:solidFill>
+                          <a:latin typeface="Calibri" pitchFamily="34" charset="0"/>
+                          <a:ea typeface="Calibri" pitchFamily="34" charset="-122"/>
+                          <a:cs typeface="Calibri" pitchFamily="34" charset="-120"/>
+                        </a:rPr>
+                        <a:t>Complete</a:t>
+                      </a:r>
+                      <a:endParaRPr lang="en-US" sz="1200" dirty="0">
+                        <a:latin typeface="Calibri" charset="0"/>
+                        <a:ea typeface="Calibri" charset="0"/>
+                        <a:cs typeface="Calibri" charset="0"/>
+                      </a:endParaRPr>
+                    </a:p>
+                  </a:txBody>
+                  <a:tcPr marL="91440" marR="91440" marT="45720" marB="45720" anchor="t">
+                    <a:lnL w="6350" cap="flat" cmpd="sng" algn="ctr">
+                      <a:solidFill>
+                        <a:srgbClr val="DDDDDD"/>
+                      </a:solidFill>
+                      <a:prstDash val="solid"/>
+                      <a:round/>
+                      <a:headEnd type="none" w="med" len="med"/>
+                      <a:tailEnd type="none" w="med" len="med"/>
+                    </a:lnL>
+                    <a:lnR w="6350" cap="flat" cmpd="sng" algn="ctr">
+                      <a:solidFill>
+                        <a:srgbClr val="DDDDDD"/>
+                      </a:solidFill>
+                      <a:prstDash val="solid"/>
+                      <a:round/>
+                      <a:headEnd type="none" w="med" len="med"/>
+                      <a:tailEnd type="none" w="med" len="med"/>
+                    </a:lnR>
+                    <a:lnT w="6350" cap="flat" cmpd="sng" algn="ctr">
+                      <a:solidFill>
+                        <a:srgbClr val="DDDDDD"/>
+                      </a:solidFill>
+                      <a:prstDash val="solid"/>
+                      <a:round/>
+                      <a:headEnd type="none" w="med" len="med"/>
+                      <a:tailEnd type="none" w="med" len="med"/>
+                    </a:lnT>
+                    <a:lnB w="6350" cap="flat" cmpd="sng" algn="ctr">
+                      <a:solidFill>
+                        <a:srgbClr val="DDDDDD"/>
+                      </a:solidFill>
+                      <a:prstDash val="solid"/>
+                      <a:round/>
+                      <a:headEnd type="none" w="med" len="med"/>
+                      <a:tailEnd type="none" w="med" len="med"/>
+                    </a:lnB>
+                  </a:tcPr>
+                </a:tc>
+              </a:tr>
+              <a:tr h="594360">
+                <a:tc>
+                  <a:txBody>
+                    <a:bodyPr/>
+                    <a:lstStyle/>
+                    <a:p>
+                      <a:pPr indent="0" marL="0">
+                        <a:buNone/>
+                      </a:pPr>
+                      <a:r>
+                        <a:rPr lang="en-US" sz="1200" dirty="0">
+                          <a:solidFill>
+                            <a:srgbClr val="000000"/>
+                          </a:solidFill>
+                          <a:latin typeface="Calibri" pitchFamily="34" charset="0"/>
+                          <a:ea typeface="Calibri" pitchFamily="34" charset="-122"/>
+                          <a:cs typeface="Calibri" pitchFamily="34" charset="-120"/>
+                        </a:rPr>
+                        <a:t>CODEOWNERS + audit logging live on private repo</a:t>
+                      </a:r>
+                      <a:endParaRPr lang="en-US" sz="1200" dirty="0">
+                        <a:latin typeface="Calibri" charset="0"/>
+                        <a:ea typeface="Calibri" charset="0"/>
+                        <a:cs typeface="Calibri" charset="0"/>
+                      </a:endParaRPr>
+                    </a:p>
+                  </a:txBody>
+                  <a:tcPr marL="91440" marR="91440" marT="45720" marB="45720" anchor="t">
+                    <a:lnL w="6350" cap="flat" cmpd="sng" algn="ctr">
+                      <a:solidFill>
+                        <a:srgbClr val="DDDDDD"/>
+                      </a:solidFill>
+                      <a:prstDash val="solid"/>
+                      <a:round/>
+                      <a:headEnd type="none" w="med" len="med"/>
+                      <a:tailEnd type="none" w="med" len="med"/>
+                    </a:lnL>
+                    <a:lnR w="6350" cap="flat" cmpd="sng" algn="ctr">
+                      <a:solidFill>
+                        <a:srgbClr val="DDDDDD"/>
+                      </a:solidFill>
+                      <a:prstDash val="solid"/>
+                      <a:round/>
+                      <a:headEnd type="none" w="med" len="med"/>
+                      <a:tailEnd type="none" w="med" len="med"/>
+                    </a:lnR>
+                    <a:lnT w="6350" cap="flat" cmpd="sng" algn="ctr">
+                      <a:solidFill>
+                        <a:srgbClr val="DDDDDD"/>
+                      </a:solidFill>
+                      <a:prstDash val="solid"/>
+                      <a:round/>
+                      <a:headEnd type="none" w="med" len="med"/>
+                      <a:tailEnd type="none" w="med" len="med"/>
+                    </a:lnT>
+                    <a:lnB w="6350" cap="flat" cmpd="sng" algn="ctr">
+                      <a:solidFill>
+                        <a:srgbClr val="DDDDDD"/>
+                      </a:solidFill>
+                      <a:prstDash val="solid"/>
+                      <a:round/>
+                      <a:headEnd type="none" w="med" len="med"/>
+                      <a:tailEnd type="none" w="med" len="med"/>
+                    </a:lnB>
+                  </a:tcPr>
+                </a:tc>
+                <a:tc>
+                  <a:txBody>
+                    <a:bodyPr/>
+                    <a:lstStyle/>
+                    <a:p>
+                      <a:pPr indent="0" marL="0">
+                        <a:buNone/>
+                      </a:pPr>
+                      <a:r>
+                        <a:rPr lang="en-US" sz="1200" dirty="0">
+                          <a:solidFill>
+                            <a:srgbClr val="000000"/>
+                          </a:solidFill>
+                          <a:latin typeface="Calibri" pitchFamily="34" charset="0"/>
+                          <a:ea typeface="Calibri" pitchFamily="34" charset="-122"/>
+                          <a:cs typeface="Calibri" pitchFamily="34" charset="-120"/>
+                        </a:rPr>
+                        <a:t>Complete</a:t>
+                      </a:r>
+                      <a:endParaRPr lang="en-US" sz="1200" dirty="0">
+                        <a:latin typeface="Calibri" charset="0"/>
+                        <a:ea typeface="Calibri" charset="0"/>
+                        <a:cs typeface="Calibri" charset="0"/>
+                      </a:endParaRPr>
+                    </a:p>
+                  </a:txBody>
+                  <a:tcPr marL="91440" marR="91440" marT="45720" marB="45720" anchor="t">
+                    <a:lnL w="6350" cap="flat" cmpd="sng" algn="ctr">
+                      <a:solidFill>
+                        <a:srgbClr val="DDDDDD"/>
+                      </a:solidFill>
+                      <a:prstDash val="solid"/>
+                      <a:round/>
+                      <a:headEnd type="none" w="med" len="med"/>
+                      <a:tailEnd type="none" w="med" len="med"/>
+                    </a:lnL>
+                    <a:lnR w="6350" cap="flat" cmpd="sng" algn="ctr">
+                      <a:solidFill>
+                        <a:srgbClr val="DDDDDD"/>
+                      </a:solidFill>
+                      <a:prstDash val="solid"/>
+                      <a:round/>
+                      <a:headEnd type="none" w="med" len="med"/>
+                      <a:tailEnd type="none" w="med" len="med"/>
+                    </a:lnR>
+                    <a:lnT w="6350" cap="flat" cmpd="sng" algn="ctr">
+                      <a:solidFill>
+                        <a:srgbClr val="DDDDDD"/>
+                      </a:solidFill>
+                      <a:prstDash val="solid"/>
+                      <a:round/>
+                      <a:headEnd type="none" w="med" len="med"/>
+                      <a:tailEnd type="none" w="med" len="med"/>
+                    </a:lnT>
+                    <a:lnB w="6350" cap="flat" cmpd="sng" algn="ctr">
+                      <a:solidFill>
+                        <a:srgbClr val="DDDDDD"/>
+                      </a:solidFill>
+                      <a:prstDash val="solid"/>
+                      <a:round/>
+                      <a:headEnd type="none" w="med" len="med"/>
+                      <a:tailEnd type="none" w="med" len="med"/>
+                    </a:lnB>
+                  </a:tcPr>
+                </a:tc>
+              </a:tr>
+              <a:tr h="594360">
+                <a:tc>
+                  <a:txBody>
+                    <a:bodyPr/>
+                    <a:lstStyle/>
+                    <a:p>
+                      <a:pPr indent="0" marL="0">
+                        <a:buNone/>
+                      </a:pPr>
+                      <a:r>
+                        <a:rPr lang="en-US" sz="1200" dirty="0">
+                          <a:solidFill>
+                            <a:srgbClr val="000000"/>
+                          </a:solidFill>
+                          <a:latin typeface="Calibri" pitchFamily="34" charset="0"/>
+                          <a:ea typeface="Calibri" pitchFamily="34" charset="-122"/>
+                          <a:cs typeface="Calibri" pitchFamily="34" charset="-120"/>
+                        </a:rPr>
+                        <a:t>Container hardening: non-root execution, pinned image tags, resource limits across all Docker/K8s configs</a:t>
+                      </a:r>
+                      <a:endParaRPr lang="en-US" sz="1200" dirty="0">
+                        <a:latin typeface="Calibri" charset="0"/>
+                        <a:ea typeface="Calibri" charset="0"/>
+                        <a:cs typeface="Calibri" charset="0"/>
+                      </a:endParaRPr>
+                    </a:p>
+                  </a:txBody>
+                  <a:tcPr marL="91440" marR="91440" marT="45720" marB="45720" anchor="t">
+                    <a:lnL w="6350" cap="flat" cmpd="sng" algn="ctr">
+                      <a:solidFill>
+                        <a:srgbClr val="DDDDDD"/>
+                      </a:solidFill>
+                      <a:prstDash val="solid"/>
+                      <a:round/>
+                      <a:headEnd type="none" w="med" len="med"/>
+                      <a:tailEnd type="none" w="med" len="med"/>
+                    </a:lnL>
+                    <a:lnR w="6350" cap="flat" cmpd="sng" algn="ctr">
+                      <a:solidFill>
+                        <a:srgbClr val="DDDDDD"/>
+                      </a:solidFill>
+                      <a:prstDash val="solid"/>
+                      <a:round/>
+                      <a:headEnd type="none" w="med" len="med"/>
+                      <a:tailEnd type="none" w="med" len="med"/>
+                    </a:lnR>
+                    <a:lnT w="6350" cap="flat" cmpd="sng" algn="ctr">
+                      <a:solidFill>
+                        <a:srgbClr val="DDDDDD"/>
+                      </a:solidFill>
+                      <a:prstDash val="solid"/>
+                      <a:round/>
+                      <a:headEnd type="none" w="med" len="med"/>
+                      <a:tailEnd type="none" w="med" len="med"/>
+                    </a:lnT>
+                    <a:lnB w="6350" cap="flat" cmpd="sng" algn="ctr">
+                      <a:solidFill>
+                        <a:srgbClr val="DDDDDD"/>
+                      </a:solidFill>
+                      <a:prstDash val="solid"/>
+                      <a:round/>
+                      <a:headEnd type="none" w="med" len="med"/>
+                      <a:tailEnd type="none" w="med" len="med"/>
+                    </a:lnB>
+                  </a:tcPr>
+                </a:tc>
+                <a:tc>
+                  <a:txBody>
+                    <a:bodyPr/>
+                    <a:lstStyle/>
+                    <a:p>
+                      <a:pPr indent="0" marL="0">
+                        <a:buNone/>
+                      </a:pPr>
+                      <a:r>
+                        <a:rPr lang="en-US" sz="1200" dirty="0">
+                          <a:solidFill>
+                            <a:srgbClr val="000000"/>
+                          </a:solidFill>
+                          <a:latin typeface="Calibri" pitchFamily="34" charset="0"/>
+                          <a:ea typeface="Calibri" pitchFamily="34" charset="-122"/>
+                          <a:cs typeface="Calibri" pitchFamily="34" charset="-120"/>
+                        </a:rPr>
+                        <a:t>Complete</a:t>
+                      </a:r>
+                      <a:endParaRPr lang="en-US" sz="1200" dirty="0">
+                        <a:latin typeface="Calibri" charset="0"/>
+                        <a:ea typeface="Calibri" charset="0"/>
+                        <a:cs typeface="Calibri" charset="0"/>
+                      </a:endParaRPr>
+                    </a:p>
+                  </a:txBody>
+                  <a:tcPr marL="91440" marR="91440" marT="45720" marB="45720" anchor="t">
+                    <a:lnL w="6350" cap="flat" cmpd="sng" algn="ctr">
+                      <a:solidFill>
+                        <a:srgbClr val="DDDDDD"/>
+                      </a:solidFill>
+                      <a:prstDash val="solid"/>
+                      <a:round/>
+                      <a:headEnd type="none" w="med" len="med"/>
+                      <a:tailEnd type="none" w="med" len="med"/>
+                    </a:lnL>
+                    <a:lnR w="6350" cap="flat" cmpd="sng" algn="ctr">
+                      <a:solidFill>
+                        <a:srgbClr val="DDDDDD"/>
+                      </a:solidFill>
+                      <a:prstDash val="solid"/>
+                      <a:round/>
+                      <a:headEnd type="none" w="med" len="med"/>
+                      <a:tailEnd type="none" w="med" len="med"/>
+                    </a:lnR>
+                    <a:lnT w="6350" cap="flat" cmpd="sng" algn="ctr">
+                      <a:solidFill>
+                        <a:srgbClr val="DDDDDD"/>
+                      </a:solidFill>
+                      <a:prstDash val="solid"/>
+                      <a:round/>
+                      <a:headEnd type="none" w="med" len="med"/>
+                      <a:tailEnd type="none" w="med" len="med"/>
+                    </a:lnT>
+                    <a:lnB w="6350" cap="flat" cmpd="sng" algn="ctr">
+                      <a:solidFill>
+                        <a:srgbClr val="DDDDDD"/>
+                      </a:solidFill>
+                      <a:prstDash val="solid"/>
+                      <a:round/>
+                      <a:headEnd type="none" w="med" len="med"/>
+                      <a:tailEnd type="none" w="med" len="med"/>
+                    </a:lnB>
+                  </a:tcPr>
+                </a:tc>
+              </a:tr>
+            </a:tbl>
+          </a:graphicData>
+        </a:graphic>
+      </p:graphicFrame>
     </p:spTree>
   </p:cSld>
   <p:clrMapOvr>

</xml_diff>

<commit_message>
Revert to original pitch deck - previous edit corrupted file
</commit_message>
<xml_diff>
--- a/GPU_Optimizer_ventureLAB_Deck.pptx
+++ b/GPU_Optimizer_ventureLAB_Deck.pptx
@@ -13,7 +13,6 @@
     <p:sldId id="261" r:id="rId7"/>
     <p:sldId id="262" r:id="rId8"/>
     <p:sldId id="263" r:id="rId9"/>
-    <p:sldId id="264" r:id="rId15"/>
   </p:sldIdLst>
   <p:notesMasterIdLst>
     <p:notesMasterId r:id="rId10"/>
@@ -4974,138 +4973,6 @@
                   </a:tcPr>
                 </a:tc>
               </a:tr>
-              <a:tr h="594360">
-                <a:tc>
-                  <a:txBody>
-                    <a:bodyPr/>
-                    <a:lstStyle/>
-                    <a:p>
-                      <a:pPr indent="0" marL="0">
-                        <a:buNone/>
-                      </a:pPr>
-                      <a:r>
-                        <a:rPr lang="en-US" sz="1200" dirty="0">
-                          <a:solidFill>
-                            <a:srgbClr val="000000"/>
-                          </a:solidFill>
-                          <a:latin typeface="Calibri" pitchFamily="34" charset="0"/>
-                          <a:ea typeface="Calibri" pitchFamily="34" charset="-122"/>
-                          <a:cs typeface="Calibri" pitchFamily="34" charset="-120"/>
-                        </a:rPr>
-                        <a:t>Security infrastructure hardened: dependency scanning, branch protection, and audit logging live across all repos</a:t>
-                      </a:r>
-                      <a:endParaRPr lang="en-US" sz="1200" dirty="0">
-                        <a:latin typeface="Calibri" charset="0"/>
-                        <a:ea typeface="Calibri" charset="0"/>
-                        <a:cs typeface="Calibri" charset="0"/>
-                      </a:endParaRPr>
-                    </a:p>
-                  </a:txBody>
-                  <a:tcPr marL="91440" marR="91440" marT="45720" marB="45720" anchor="t">
-                    <a:lnL w="6350" cap="flat" cmpd="sng" algn="ctr">
-                      <a:solidFill>
-                        <a:srgbClr val="DDDDDD"/>
-                      </a:solidFill>
-                      <a:prstDash val="solid"/>
-                      <a:round/>
-                      <a:headEnd type="none" w="med" len="med"/>
-                      <a:tailEnd type="none" w="med" len="med"/>
-                    </a:lnL>
-                    <a:lnR w="6350" cap="flat" cmpd="sng" algn="ctr">
-                      <a:solidFill>
-                        <a:srgbClr val="DDDDDD"/>
-                      </a:solidFill>
-                      <a:prstDash val="solid"/>
-                      <a:round/>
-                      <a:headEnd type="none" w="med" len="med"/>
-                      <a:tailEnd type="none" w="med" len="med"/>
-                    </a:lnR>
-                    <a:lnT w="6350" cap="flat" cmpd="sng" algn="ctr">
-                      <a:solidFill>
-                        <a:srgbClr val="DDDDDD"/>
-                      </a:solidFill>
-                      <a:prstDash val="solid"/>
-                      <a:round/>
-                      <a:headEnd type="none" w="med" len="med"/>
-                      <a:tailEnd type="none" w="med" len="med"/>
-                    </a:lnT>
-                    <a:lnB w="6350" cap="flat" cmpd="sng" algn="ctr">
-                      <a:solidFill>
-                        <a:srgbClr val="DDDDDD"/>
-                      </a:solidFill>
-                      <a:prstDash val="solid"/>
-                      <a:round/>
-                      <a:headEnd type="none" w="med" len="med"/>
-                      <a:tailEnd type="none" w="med" len="med"/>
-                    </a:lnB>
-                  </a:tcPr>
-                </a:tc>
-                <a:tc>
-                  <a:txBody>
-                    <a:bodyPr/>
-                    <a:lstStyle/>
-                    <a:p>
-                      <a:pPr indent="0" marL="0">
-                        <a:buNone/>
-                      </a:pPr>
-                      <a:r>
-                        <a:rPr lang="en-US" sz="1200" dirty="0">
-                          <a:solidFill>
-                            <a:srgbClr val="000000"/>
-                          </a:solidFill>
-                          <a:latin typeface="Calibri" pitchFamily="34" charset="0"/>
-                          <a:ea typeface="Calibri" pitchFamily="34" charset="-122"/>
-                          <a:cs typeface="Calibri" pitchFamily="34" charset="-120"/>
-                        </a:rPr>
-                        <a:t/>
-                      </a:r>
-                      <a:endParaRPr lang="en-US" sz="1200" dirty="0">
-                        <a:latin typeface="Calibri" charset="0"/>
-                        <a:ea typeface="Calibri" charset="0"/>
-                        <a:cs typeface="Calibri" charset="0"/>
-                      </a:endParaRPr>
-                    </a:p>
-                  </a:txBody>
-                  <a:tcPr marL="91440" marR="91440" marT="45720" marB="45720" anchor="t">
-                    <a:lnL w="6350" cap="flat" cmpd="sng" algn="ctr">
-                      <a:solidFill>
-                        <a:srgbClr val="DDDDDD"/>
-                      </a:solidFill>
-                      <a:prstDash val="solid"/>
-                      <a:round/>
-                      <a:headEnd type="none" w="med" len="med"/>
-                      <a:tailEnd type="none" w="med" len="med"/>
-                    </a:lnL>
-                    <a:lnR w="6350" cap="flat" cmpd="sng" algn="ctr">
-                      <a:solidFill>
-                        <a:srgbClr val="DDDDDD"/>
-                      </a:solidFill>
-                      <a:prstDash val="solid"/>
-                      <a:round/>
-                      <a:headEnd type="none" w="med" len="med"/>
-                      <a:tailEnd type="none" w="med" len="med"/>
-                    </a:lnR>
-                    <a:lnT w="6350" cap="flat" cmpd="sng" algn="ctr">
-                      <a:solidFill>
-                        <a:srgbClr val="DDDDDD"/>
-                      </a:solidFill>
-                      <a:prstDash val="solid"/>
-                      <a:round/>
-                      <a:headEnd type="none" w="med" len="med"/>
-                      <a:tailEnd type="none" w="med" len="med"/>
-                    </a:lnT>
-                    <a:lnB w="6350" cap="flat" cmpd="sng" algn="ctr">
-                      <a:solidFill>
-                        <a:srgbClr val="DDDDDD"/>
-                      </a:solidFill>
-                      <a:prstDash val="solid"/>
-                      <a:round/>
-                      <a:headEnd type="none" w="med" len="med"/>
-                      <a:tailEnd type="none" w="med" len="med"/>
-                    </a:lnB>
-                  </a:tcPr>
-                </a:tc>
-              </a:tr>
             </a:tbl>
           </a:graphicData>
         </a:graphic>
@@ -5743,851 +5610,6 @@
           </a:p>
         </p:txBody>
       </p:sp>
-    </p:spTree>
-  </p:cSld>
-  <p:clrMapOvr>
-    <a:masterClrMapping/>
-  </p:clrMapOvr>
-</p:sld>
-</file>
-
-<file path=ppt/slides/slide9.xml><?xml version="1.0" encoding="utf-8"?>
-<p:sld xmlns:a="http://schemas.openxmlformats.org/drawingml/2006/main" xmlns:r="http://schemas.openxmlformats.org/officeDocument/2006/relationships" xmlns:p="http://schemas.openxmlformats.org/presentationml/2006/main">
-  <p:cSld name="Slide 7">
-    <p:bg>
-      <p:bgPr>
-        <a:solidFill>
-          <a:srgbClr val="FFFFFF"/>
-        </a:solidFill>
-      </p:bgPr>
-    </p:bg>
-    <p:spTree>
-      <p:nvGrpSpPr>
-        <p:cNvPr id="1" name=""/>
-        <p:cNvGrpSpPr/>
-        <p:nvPr/>
-      </p:nvGrpSpPr>
-      <p:grpSpPr>
-        <a:xfrm>
-          <a:off x="0" y="0"/>
-          <a:ext cx="0" cy="0"/>
-          <a:chOff x="0" y="0"/>
-          <a:chExt cx="0" cy="0"/>
-        </a:xfrm>
-      </p:grpSpPr>
-      <p:sp>
-        <p:nvSpPr>
-          <p:cNvPr id="2" name="Text 0"/>
-          <p:cNvSpPr/>
-          <p:nvPr/>
-        </p:nvSpPr>
-        <p:spPr>
-          <a:xfrm>
-            <a:off x="548640" y="365760"/>
-            <a:ext cx="9144000" cy="320040"/>
-          </a:xfrm>
-          <a:prstGeom prst="rect">
-            <a:avLst/>
-          </a:prstGeom>
-          <a:noFill/>
-          <a:ln/>
-        </p:spPr>
-        <p:txBody>
-          <a:bodyPr wrap="square" rtlCol="0" anchor="ctr"/>
-          <a:lstStyle/>
-          <a:p>
-            <a:pPr indent="0" marL="0">
-              <a:buNone/>
-            </a:pPr>
-            <a:r>
-              <a:rPr lang="en-US" sz="1100" b="1" spc="200" kern="0" dirty="0">
-                <a:solidFill>
-                  <a:srgbClr val="1E2761"/>
-                </a:solidFill>
-                <a:latin typeface="Calibri" pitchFamily="34" charset="0"/>
-                <a:ea typeface="Calibri" pitchFamily="34" charset="-122"/>
-                <a:cs typeface="Calibri" pitchFamily="34" charset="-120"/>
-              </a:rPr>
-              <a:t>APPENDIX</a:t>
-            </a:r>
-            <a:endParaRPr lang="en-US" sz="1100" dirty="0"/>
-          </a:p>
-        </p:txBody>
-      </p:sp>
-      <p:sp>
-        <p:nvSpPr>
-          <p:cNvPr id="3" name="Text 1"/>
-          <p:cNvSpPr/>
-          <p:nvPr/>
-        </p:nvSpPr>
-        <p:spPr>
-          <a:xfrm>
-            <a:off x="548640" y="685800"/>
-            <a:ext cx="10789920" cy="731520"/>
-          </a:xfrm>
-          <a:prstGeom prst="rect">
-            <a:avLst/>
-          </a:prstGeom>
-          <a:noFill/>
-          <a:ln/>
-        </p:spPr>
-        <p:txBody>
-          <a:bodyPr wrap="square" rtlCol="0" anchor="ctr"/>
-          <a:lstStyle/>
-          <a:p>
-            <a:pPr indent="0" marL="0">
-              <a:buNone/>
-            </a:pPr>
-            <a:r>
-              <a:rPr lang="en-US" sz="2600" b="1" dirty="0">
-                <a:solidFill>
-                  <a:srgbClr val="1E1E2E"/>
-                </a:solidFill>
-                <a:latin typeface="Cambria" pitchFamily="34" charset="0"/>
-                <a:ea typeface="Cambria" pitchFamily="34" charset="-122"/>
-                <a:cs typeface="Cambria" pitchFamily="34" charset="-120"/>
-              </a:rPr>
-              <a:t>Security Posture as of 2026-07-09</a:t>
-            </a:r>
-            <a:endParaRPr lang="en-US" sz="2600" dirty="0"/>
-          </a:p>
-        </p:txBody>
-      </p:sp>
-      <p:sp>
-        <p:nvSpPr>
-          <p:cNvPr id="4" name="Text 2"/>
-          <p:cNvSpPr/>
-          <p:nvPr/>
-        </p:nvSpPr>
-        <p:spPr>
-          <a:xfrm>
-            <a:off x="548640" y="1463040"/>
-            <a:ext cx="10789920" cy="457200"/>
-          </a:xfrm>
-          <a:prstGeom prst="rect">
-            <a:avLst/>
-          </a:prstGeom>
-          <a:noFill/>
-          <a:ln/>
-        </p:spPr>
-        <p:txBody>
-          <a:bodyPr wrap="square" rtlCol="0" anchor="ctr"/>
-          <a:lstStyle/>
-          <a:p>
-            <a:pPr indent="0" marL="0">
-              <a:buNone/>
-            </a:pPr>
-            <a:r>
-              <a:rPr lang="en-US" sz="1450" b="1" dirty="0">
-                <a:solidFill>
-                  <a:srgbClr val="1E1E2E"/>
-                </a:solidFill>
-                <a:latin typeface="Calibri" pitchFamily="34" charset="0"/>
-                <a:ea typeface="Calibri" pitchFamily="34" charset="-122"/>
-                <a:cs typeface="Calibri" pitchFamily="34" charset="-120"/>
-              </a:rPr>
-              <a:t>We de-risked the #1 reason enterprise deals die in procurement: security questionnaires.</a:t>
-            </a:r>
-            <a:endParaRPr lang="en-US" sz="1450" dirty="0"/>
-          </a:p>
-        </p:txBody>
-      </p:sp>
-      <p:graphicFrame>
-        <p:nvGraphicFramePr>
-          <p:cNvPr id="8" name="Table 0"/>
-          <p:cNvGraphicFramePr>
-            <a:graphicFrameLocks noGrp="1"/>
-          </p:cNvGraphicFramePr>
-          <p:nvPr>
-            <p:extLst>
-              <p:ext uri="{D42A27DB-BD31-4B8C-83A1-F6EECF244321}">
-                <p14:modId xmlns:p14="http://schemas.microsoft.com/office/powerpoint/2010/main" val="1579011935"/>
-              </p:ext>
-            </p:extLst>
-          </p:nvPr>
-        </p:nvGraphicFramePr>
-        <p:xfrm>
-          <a:off x="548640" y="2011680"/>
-          <a:ext cx="10789920" cy="2377440"/>
-        </p:xfrm>
-        <a:graphic>
-          <a:graphicData uri="http://schemas.openxmlformats.org/drawingml/2006/table">
-            <a:tbl>
-              <a:tblPr/>
-              <a:tblGrid>
-                <a:gridCol w="5394960"/>
-                <a:gridCol w="5394960"/>
-              </a:tblGrid>
-              <a:tr h="594360">
-                <a:tc>
-                  <a:txBody>
-                    <a:bodyPr/>
-                    <a:lstStyle/>
-                    <a:p>
-                      <a:pPr indent="0" marL="0">
-                        <a:buNone/>
-                      </a:pPr>
-                      <a:r>
-                        <a:rPr lang="en-US" sz="1200" b="1" dirty="0">
-                          <a:solidFill>
-                            <a:srgbClr val="FFFFFF"/>
-                          </a:solidFill>
-                          <a:latin typeface="Calibri" pitchFamily="34" charset="0"/>
-                          <a:ea typeface="Calibri" pitchFamily="34" charset="-122"/>
-                          <a:cs typeface="Calibri" pitchFamily="34" charset="-120"/>
-                        </a:rPr>
-                        <a:t>Technical Controls</a:t>
-                      </a:r>
-                      <a:endParaRPr lang="en-US" sz="1200" dirty="0">
-                        <a:latin typeface="Calibri" charset="0"/>
-                        <a:ea typeface="Calibri" charset="0"/>
-                        <a:cs typeface="Calibri" charset="0"/>
-                      </a:endParaRPr>
-                    </a:p>
-                  </a:txBody>
-                  <a:tcPr marL="91440" marR="91440" marT="45720" marB="45720" anchor="t">
-                    <a:lnL w="6350" cap="flat" cmpd="sng" algn="ctr">
-                      <a:solidFill>
-                        <a:srgbClr val="DDDDDD"/>
-                      </a:solidFill>
-                      <a:prstDash val="solid"/>
-                      <a:round/>
-                      <a:headEnd type="none" w="med" len="med"/>
-                      <a:tailEnd type="none" w="med" len="med"/>
-                    </a:lnL>
-                    <a:lnR w="6350" cap="flat" cmpd="sng" algn="ctr">
-                      <a:solidFill>
-                        <a:srgbClr val="DDDDDD"/>
-                      </a:solidFill>
-                      <a:prstDash val="solid"/>
-                      <a:round/>
-                      <a:headEnd type="none" w="med" len="med"/>
-                      <a:tailEnd type="none" w="med" len="med"/>
-                    </a:lnR>
-                    <a:lnT w="6350" cap="flat" cmpd="sng" algn="ctr">
-                      <a:solidFill>
-                        <a:srgbClr val="DDDDDD"/>
-                      </a:solidFill>
-                      <a:prstDash val="solid"/>
-                      <a:round/>
-                      <a:headEnd type="none" w="med" len="med"/>
-                      <a:tailEnd type="none" w="med" len="med"/>
-                    </a:lnT>
-                    <a:lnB w="6350" cap="flat" cmpd="sng" algn="ctr">
-                      <a:solidFill>
-                        <a:srgbClr val="DDDDDD"/>
-                      </a:solidFill>
-                      <a:prstDash val="solid"/>
-                      <a:round/>
-                      <a:headEnd type="none" w="med" len="med"/>
-                      <a:tailEnd type="none" w="med" len="med"/>
-                    </a:lnB>
-                    <a:solidFill>
-                      <a:srgbClr val="1F9D55"/>
-                    </a:solidFill>
-                  </a:tcPr>
-                </a:tc>
-                <a:tc>
-                  <a:txBody>
-                    <a:bodyPr/>
-                    <a:lstStyle/>
-                    <a:p>
-                      <a:pPr indent="0" marL="0">
-                        <a:buNone/>
-                      </a:pPr>
-                      <a:r>
-                        <a:rPr lang="en-US" sz="1200" b="1" dirty="0">
-                          <a:solidFill>
-                            <a:srgbClr val="FFFFFF"/>
-                          </a:solidFill>
-                          <a:latin typeface="Calibri" pitchFamily="34" charset="0"/>
-                          <a:ea typeface="Calibri" pitchFamily="34" charset="-122"/>
-                          <a:cs typeface="Calibri" pitchFamily="34" charset="-120"/>
-                        </a:rPr>
-                        <a:t>Status</a:t>
-                      </a:r>
-                      <a:endParaRPr lang="en-US" sz="1200" dirty="0">
-                        <a:latin typeface="Calibri" charset="0"/>
-                        <a:ea typeface="Calibri" charset="0"/>
-                        <a:cs typeface="Calibri" charset="0"/>
-                      </a:endParaRPr>
-                    </a:p>
-                  </a:txBody>
-                  <a:tcPr marL="91440" marR="91440" marT="45720" marB="45720" anchor="t">
-                    <a:lnL w="6350" cap="flat" cmpd="sng" algn="ctr">
-                      <a:solidFill>
-                        <a:srgbClr val="DDDDDD"/>
-                      </a:solidFill>
-                      <a:prstDash val="solid"/>
-                      <a:round/>
-                      <a:headEnd type="none" w="med" len="med"/>
-                      <a:tailEnd type="none" w="med" len="med"/>
-                    </a:lnL>
-                    <a:lnR w="6350" cap="flat" cmpd="sng" algn="ctr">
-                      <a:solidFill>
-                        <a:srgbClr val="DDDDDD"/>
-                      </a:solidFill>
-                      <a:prstDash val="solid"/>
-                      <a:round/>
-                      <a:headEnd type="none" w="med" len="med"/>
-                      <a:tailEnd type="none" w="med" len="med"/>
-                    </a:lnR>
-                    <a:lnT w="6350" cap="flat" cmpd="sng" algn="ctr">
-                      <a:solidFill>
-                        <a:srgbClr val="DDDDDD"/>
-                      </a:solidFill>
-                      <a:prstDash val="solid"/>
-                      <a:round/>
-                      <a:headEnd type="none" w="med" len="med"/>
-                      <a:tailEnd type="none" w="med" len="med"/>
-                    </a:lnT>
-                    <a:lnB w="6350" cap="flat" cmpd="sng" algn="ctr">
-                      <a:solidFill>
-                        <a:srgbClr val="DDDDDD"/>
-                      </a:solidFill>
-                      <a:prstDash val="solid"/>
-                      <a:round/>
-                      <a:headEnd type="none" w="med" len="med"/>
-                      <a:tailEnd type="none" w="med" len="med"/>
-                    </a:lnB>
-                    <a:solidFill>
-                      <a:srgbClr val="8A8A8A"/>
-                    </a:solidFill>
-                  </a:tcPr>
-                </a:tc>
-              </a:tr>
-              <a:tr h="594360">
-                <a:tc>
-                  <a:txBody>
-                    <a:bodyPr/>
-                    <a:lstStyle/>
-                    <a:p>
-                      <a:pPr indent="0" marL="0">
-                        <a:buNone/>
-                      </a:pPr>
-                      <a:r>
-                        <a:rPr lang="en-US" sz="1200" dirty="0">
-                          <a:solidFill>
-                            <a:srgbClr val="000000"/>
-                          </a:solidFill>
-                          <a:latin typeface="Calibri" pitchFamily="34" charset="0"/>
-                          <a:ea typeface="Calibri" pitchFamily="34" charset="-122"/>
-                          <a:cs typeface="Calibri" pitchFamily="34" charset="-120"/>
-                        </a:rPr>
-                        <a:t>0 known CVEs (patched CVE-2025-69223, CVSS 7.5, aiohttp zip-bomb DoS, among others)</a:t>
-                      </a:r>
-                      <a:endParaRPr lang="en-US" sz="1200" dirty="0">
-                        <a:latin typeface="Calibri" charset="0"/>
-                        <a:ea typeface="Calibri" charset="0"/>
-                        <a:cs typeface="Calibri" charset="0"/>
-                      </a:endParaRPr>
-                    </a:p>
-                  </a:txBody>
-                  <a:tcPr marL="91440" marR="91440" marT="45720" marB="45720" anchor="t">
-                    <a:lnL w="6350" cap="flat" cmpd="sng" algn="ctr">
-                      <a:solidFill>
-                        <a:srgbClr val="DDDDDD"/>
-                      </a:solidFill>
-                      <a:prstDash val="solid"/>
-                      <a:round/>
-                      <a:headEnd type="none" w="med" len="med"/>
-                      <a:tailEnd type="none" w="med" len="med"/>
-                    </a:lnL>
-                    <a:lnR w="6350" cap="flat" cmpd="sng" algn="ctr">
-                      <a:solidFill>
-                        <a:srgbClr val="DDDDDD"/>
-                      </a:solidFill>
-                      <a:prstDash val="solid"/>
-                      <a:round/>
-                      <a:headEnd type="none" w="med" len="med"/>
-                      <a:tailEnd type="none" w="med" len="med"/>
-                    </a:lnR>
-                    <a:lnT w="6350" cap="flat" cmpd="sng" algn="ctr">
-                      <a:solidFill>
-                        <a:srgbClr val="DDDDDD"/>
-                      </a:solidFill>
-                      <a:prstDash val="solid"/>
-                      <a:round/>
-                      <a:headEnd type="none" w="med" len="med"/>
-                      <a:tailEnd type="none" w="med" len="med"/>
-                    </a:lnT>
-                    <a:lnB w="6350" cap="flat" cmpd="sng" algn="ctr">
-                      <a:solidFill>
-                        <a:srgbClr val="DDDDDD"/>
-                      </a:solidFill>
-                      <a:prstDash val="solid"/>
-                      <a:round/>
-                      <a:headEnd type="none" w="med" len="med"/>
-                      <a:tailEnd type="none" w="med" len="med"/>
-                    </a:lnB>
-                  </a:tcPr>
-                </a:tc>
-                <a:tc>
-                  <a:txBody>
-                    <a:bodyPr/>
-                    <a:lstStyle/>
-                    <a:p>
-                      <a:pPr indent="0" marL="0">
-                        <a:buNone/>
-                      </a:pPr>
-                      <a:r>
-                        <a:rPr lang="en-US" sz="1200" dirty="0">
-                          <a:solidFill>
-                            <a:srgbClr val="000000"/>
-                          </a:solidFill>
-                          <a:latin typeface="Calibri" pitchFamily="34" charset="0"/>
-                          <a:ea typeface="Calibri" pitchFamily="34" charset="-122"/>
-                          <a:cs typeface="Calibri" pitchFamily="34" charset="-120"/>
-                        </a:rPr>
-                        <a:t>Complete</a:t>
-                      </a:r>
-                      <a:endParaRPr lang="en-US" sz="1200" dirty="0">
-                        <a:latin typeface="Calibri" charset="0"/>
-                        <a:ea typeface="Calibri" charset="0"/>
-                        <a:cs typeface="Calibri" charset="0"/>
-                      </a:endParaRPr>
-                    </a:p>
-                  </a:txBody>
-                  <a:tcPr marL="91440" marR="91440" marT="45720" marB="45720" anchor="t">
-                    <a:lnL w="6350" cap="flat" cmpd="sng" algn="ctr">
-                      <a:solidFill>
-                        <a:srgbClr val="DDDDDD"/>
-                      </a:solidFill>
-                      <a:prstDash val="solid"/>
-                      <a:round/>
-                      <a:headEnd type="none" w="med" len="med"/>
-                      <a:tailEnd type="none" w="med" len="med"/>
-                    </a:lnL>
-                    <a:lnR w="6350" cap="flat" cmpd="sng" algn="ctr">
-                      <a:solidFill>
-                        <a:srgbClr val="DDDDDD"/>
-                      </a:solidFill>
-                      <a:prstDash val="solid"/>
-                      <a:round/>
-                      <a:headEnd type="none" w="med" len="med"/>
-                      <a:tailEnd type="none" w="med" len="med"/>
-                    </a:lnR>
-                    <a:lnT w="6350" cap="flat" cmpd="sng" algn="ctr">
-                      <a:solidFill>
-                        <a:srgbClr val="DDDDDD"/>
-                      </a:solidFill>
-                      <a:prstDash val="solid"/>
-                      <a:round/>
-                      <a:headEnd type="none" w="med" len="med"/>
-                      <a:tailEnd type="none" w="med" len="med"/>
-                    </a:lnT>
-                    <a:lnB w="6350" cap="flat" cmpd="sng" algn="ctr">
-                      <a:solidFill>
-                        <a:srgbClr val="DDDDDD"/>
-                      </a:solidFill>
-                      <a:prstDash val="solid"/>
-                      <a:round/>
-                      <a:headEnd type="none" w="med" len="med"/>
-                      <a:tailEnd type="none" w="med" len="med"/>
-                    </a:lnB>
-                  </a:tcPr>
-                </a:tc>
-              </a:tr>
-              <a:tr h="594360">
-                <a:tc>
-                  <a:txBody>
-                    <a:bodyPr/>
-                    <a:lstStyle/>
-                    <a:p>
-                      <a:pPr indent="0" marL="0">
-                        <a:buNone/>
-                      </a:pPr>
-                      <a:r>
-                        <a:rPr lang="en-US" sz="1200" dirty="0">
-                          <a:solidFill>
-                            <a:srgbClr val="000000"/>
-                          </a:solidFill>
-                          <a:latin typeface="Calibri" pitchFamily="34" charset="0"/>
-                          <a:ea typeface="Calibri" pitchFamily="34" charset="-122"/>
-                          <a:cs typeface="Calibri" pitchFamily="34" charset="-120"/>
-                        </a:rPr>
-                        <a:t>Branch protection enforced: PR required, force-push blocked, deletion blocked</a:t>
-                      </a:r>
-                      <a:endParaRPr lang="en-US" sz="1200" dirty="0">
-                        <a:latin typeface="Calibri" charset="0"/>
-                        <a:ea typeface="Calibri" charset="0"/>
-                        <a:cs typeface="Calibri" charset="0"/>
-                      </a:endParaRPr>
-                    </a:p>
-                  </a:txBody>
-                  <a:tcPr marL="91440" marR="91440" marT="45720" marB="45720" anchor="t">
-                    <a:lnL w="6350" cap="flat" cmpd="sng" algn="ctr">
-                      <a:solidFill>
-                        <a:srgbClr val="DDDDDD"/>
-                      </a:solidFill>
-                      <a:prstDash val="solid"/>
-                      <a:round/>
-                      <a:headEnd type="none" w="med" len="med"/>
-                      <a:tailEnd type="none" w="med" len="med"/>
-                    </a:lnL>
-                    <a:lnR w="6350" cap="flat" cmpd="sng" algn="ctr">
-                      <a:solidFill>
-                        <a:srgbClr val="DDDDDD"/>
-                      </a:solidFill>
-                      <a:prstDash val="solid"/>
-                      <a:round/>
-                      <a:headEnd type="none" w="med" len="med"/>
-                      <a:tailEnd type="none" w="med" len="med"/>
-                    </a:lnR>
-                    <a:lnT w="6350" cap="flat" cmpd="sng" algn="ctr">
-                      <a:solidFill>
-                        <a:srgbClr val="DDDDDD"/>
-                      </a:solidFill>
-                      <a:prstDash val="solid"/>
-                      <a:round/>
-                      <a:headEnd type="none" w="med" len="med"/>
-                      <a:tailEnd type="none" w="med" len="med"/>
-                    </a:lnT>
-                    <a:lnB w="6350" cap="flat" cmpd="sng" algn="ctr">
-                      <a:solidFill>
-                        <a:srgbClr val="DDDDDD"/>
-                      </a:solidFill>
-                      <a:prstDash val="solid"/>
-                      <a:round/>
-                      <a:headEnd type="none" w="med" len="med"/>
-                      <a:tailEnd type="none" w="med" len="med"/>
-                    </a:lnB>
-                  </a:tcPr>
-                </a:tc>
-                <a:tc>
-                  <a:txBody>
-                    <a:bodyPr/>
-                    <a:lstStyle/>
-                    <a:p>
-                      <a:pPr indent="0" marL="0">
-                        <a:buNone/>
-                      </a:pPr>
-                      <a:r>
-                        <a:rPr lang="en-US" sz="1200" dirty="0">
-                          <a:solidFill>
-                            <a:srgbClr val="000000"/>
-                          </a:solidFill>
-                          <a:latin typeface="Calibri" pitchFamily="34" charset="0"/>
-                          <a:ea typeface="Calibri" pitchFamily="34" charset="-122"/>
-                          <a:cs typeface="Calibri" pitchFamily="34" charset="-120"/>
-                        </a:rPr>
-                        <a:t>Complete</a:t>
-                      </a:r>
-                      <a:endParaRPr lang="en-US" sz="1200" dirty="0">
-                        <a:latin typeface="Calibri" charset="0"/>
-                        <a:ea typeface="Calibri" charset="0"/>
-                        <a:cs typeface="Calibri" charset="0"/>
-                      </a:endParaRPr>
-                    </a:p>
-                  </a:txBody>
-                  <a:tcPr marL="91440" marR="91440" marT="45720" marB="45720" anchor="t">
-                    <a:lnL w="6350" cap="flat" cmpd="sng" algn="ctr">
-                      <a:solidFill>
-                        <a:srgbClr val="DDDDDD"/>
-                      </a:solidFill>
-                      <a:prstDash val="solid"/>
-                      <a:round/>
-                      <a:headEnd type="none" w="med" len="med"/>
-                      <a:tailEnd type="none" w="med" len="med"/>
-                    </a:lnL>
-                    <a:lnR w="6350" cap="flat" cmpd="sng" algn="ctr">
-                      <a:solidFill>
-                        <a:srgbClr val="DDDDDD"/>
-                      </a:solidFill>
-                      <a:prstDash val="solid"/>
-                      <a:round/>
-                      <a:headEnd type="none" w="med" len="med"/>
-                      <a:tailEnd type="none" w="med" len="med"/>
-                    </a:lnR>
-                    <a:lnT w="6350" cap="flat" cmpd="sng" algn="ctr">
-                      <a:solidFill>
-                        <a:srgbClr val="DDDDDD"/>
-                      </a:solidFill>
-                      <a:prstDash val="solid"/>
-                      <a:round/>
-                      <a:headEnd type="none" w="med" len="med"/>
-                      <a:tailEnd type="none" w="med" len="med"/>
-                    </a:lnT>
-                    <a:lnB w="6350" cap="flat" cmpd="sng" algn="ctr">
-                      <a:solidFill>
-                        <a:srgbClr val="DDDDDD"/>
-                      </a:solidFill>
-                      <a:prstDash val="solid"/>
-                      <a:round/>
-                      <a:headEnd type="none" w="med" len="med"/>
-                      <a:tailEnd type="none" w="med" len="med"/>
-                    </a:lnB>
-                  </a:tcPr>
-                </a:tc>
-              </a:tr>
-              <a:tr h="594360">
-                <a:tc>
-                  <a:txBody>
-                    <a:bodyPr/>
-                    <a:lstStyle/>
-                    <a:p>
-                      <a:pPr indent="0" marL="0">
-                        <a:buNone/>
-                      </a:pPr>
-                      <a:r>
-                        <a:rPr lang="en-US" sz="1200" dirty="0">
-                          <a:solidFill>
-                            <a:srgbClr val="000000"/>
-                          </a:solidFill>
-                          <a:latin typeface="Calibri" pitchFamily="34" charset="0"/>
-                          <a:ea typeface="Calibri" pitchFamily="34" charset="-122"/>
-                          <a:cs typeface="Calibri" pitchFamily="34" charset="-120"/>
-                        </a:rPr>
-                        <a:t>CODEOWNERS + audit logging live on private repo</a:t>
-                      </a:r>
-                      <a:endParaRPr lang="en-US" sz="1200" dirty="0">
-                        <a:latin typeface="Calibri" charset="0"/>
-                        <a:ea typeface="Calibri" charset="0"/>
-                        <a:cs typeface="Calibri" charset="0"/>
-                      </a:endParaRPr>
-                    </a:p>
-                  </a:txBody>
-                  <a:tcPr marL="91440" marR="91440" marT="45720" marB="45720" anchor="t">
-                    <a:lnL w="6350" cap="flat" cmpd="sng" algn="ctr">
-                      <a:solidFill>
-                        <a:srgbClr val="DDDDDD"/>
-                      </a:solidFill>
-                      <a:prstDash val="solid"/>
-                      <a:round/>
-                      <a:headEnd type="none" w="med" len="med"/>
-                      <a:tailEnd type="none" w="med" len="med"/>
-                    </a:lnL>
-                    <a:lnR w="6350" cap="flat" cmpd="sng" algn="ctr">
-                      <a:solidFill>
-                        <a:srgbClr val="DDDDDD"/>
-                      </a:solidFill>
-                      <a:prstDash val="solid"/>
-                      <a:round/>
-                      <a:headEnd type="none" w="med" len="med"/>
-                      <a:tailEnd type="none" w="med" len="med"/>
-                    </a:lnR>
-                    <a:lnT w="6350" cap="flat" cmpd="sng" algn="ctr">
-                      <a:solidFill>
-                        <a:srgbClr val="DDDDDD"/>
-                      </a:solidFill>
-                      <a:prstDash val="solid"/>
-                      <a:round/>
-                      <a:headEnd type="none" w="med" len="med"/>
-                      <a:tailEnd type="none" w="med" len="med"/>
-                    </a:lnT>
-                    <a:lnB w="6350" cap="flat" cmpd="sng" algn="ctr">
-                      <a:solidFill>
-                        <a:srgbClr val="DDDDDD"/>
-                      </a:solidFill>
-                      <a:prstDash val="solid"/>
-                      <a:round/>
-                      <a:headEnd type="none" w="med" len="med"/>
-                      <a:tailEnd type="none" w="med" len="med"/>
-                    </a:lnB>
-                  </a:tcPr>
-                </a:tc>
-                <a:tc>
-                  <a:txBody>
-                    <a:bodyPr/>
-                    <a:lstStyle/>
-                    <a:p>
-                      <a:pPr indent="0" marL="0">
-                        <a:buNone/>
-                      </a:pPr>
-                      <a:r>
-                        <a:rPr lang="en-US" sz="1200" dirty="0">
-                          <a:solidFill>
-                            <a:srgbClr val="000000"/>
-                          </a:solidFill>
-                          <a:latin typeface="Calibri" pitchFamily="34" charset="0"/>
-                          <a:ea typeface="Calibri" pitchFamily="34" charset="-122"/>
-                          <a:cs typeface="Calibri" pitchFamily="34" charset="-120"/>
-                        </a:rPr>
-                        <a:t>Complete</a:t>
-                      </a:r>
-                      <a:endParaRPr lang="en-US" sz="1200" dirty="0">
-                        <a:latin typeface="Calibri" charset="0"/>
-                        <a:ea typeface="Calibri" charset="0"/>
-                        <a:cs typeface="Calibri" charset="0"/>
-                      </a:endParaRPr>
-                    </a:p>
-                  </a:txBody>
-                  <a:tcPr marL="91440" marR="91440" marT="45720" marB="45720" anchor="t">
-                    <a:lnL w="6350" cap="flat" cmpd="sng" algn="ctr">
-                      <a:solidFill>
-                        <a:srgbClr val="DDDDDD"/>
-                      </a:solidFill>
-                      <a:prstDash val="solid"/>
-                      <a:round/>
-                      <a:headEnd type="none" w="med" len="med"/>
-                      <a:tailEnd type="none" w="med" len="med"/>
-                    </a:lnL>
-                    <a:lnR w="6350" cap="flat" cmpd="sng" algn="ctr">
-                      <a:solidFill>
-                        <a:srgbClr val="DDDDDD"/>
-                      </a:solidFill>
-                      <a:prstDash val="solid"/>
-                      <a:round/>
-                      <a:headEnd type="none" w="med" len="med"/>
-                      <a:tailEnd type="none" w="med" len="med"/>
-                    </a:lnR>
-                    <a:lnT w="6350" cap="flat" cmpd="sng" algn="ctr">
-                      <a:solidFill>
-                        <a:srgbClr val="DDDDDD"/>
-                      </a:solidFill>
-                      <a:prstDash val="solid"/>
-                      <a:round/>
-                      <a:headEnd type="none" w="med" len="med"/>
-                      <a:tailEnd type="none" w="med" len="med"/>
-                    </a:lnT>
-                    <a:lnB w="6350" cap="flat" cmpd="sng" algn="ctr">
-                      <a:solidFill>
-                        <a:srgbClr val="DDDDDD"/>
-                      </a:solidFill>
-                      <a:prstDash val="solid"/>
-                      <a:round/>
-                      <a:headEnd type="none" w="med" len="med"/>
-                      <a:tailEnd type="none" w="med" len="med"/>
-                    </a:lnB>
-                  </a:tcPr>
-                </a:tc>
-              </a:tr>
-              <a:tr h="594360">
-                <a:tc>
-                  <a:txBody>
-                    <a:bodyPr/>
-                    <a:lstStyle/>
-                    <a:p>
-                      <a:pPr indent="0" marL="0">
-                        <a:buNone/>
-                      </a:pPr>
-                      <a:r>
-                        <a:rPr lang="en-US" sz="1200" dirty="0">
-                          <a:solidFill>
-                            <a:srgbClr val="000000"/>
-                          </a:solidFill>
-                          <a:latin typeface="Calibri" pitchFamily="34" charset="0"/>
-                          <a:ea typeface="Calibri" pitchFamily="34" charset="-122"/>
-                          <a:cs typeface="Calibri" pitchFamily="34" charset="-120"/>
-                        </a:rPr>
-                        <a:t>Container hardening: non-root execution, pinned image tags, resource limits across all Docker/K8s configs</a:t>
-                      </a:r>
-                      <a:endParaRPr lang="en-US" sz="1200" dirty="0">
-                        <a:latin typeface="Calibri" charset="0"/>
-                        <a:ea typeface="Calibri" charset="0"/>
-                        <a:cs typeface="Calibri" charset="0"/>
-                      </a:endParaRPr>
-                    </a:p>
-                  </a:txBody>
-                  <a:tcPr marL="91440" marR="91440" marT="45720" marB="45720" anchor="t">
-                    <a:lnL w="6350" cap="flat" cmpd="sng" algn="ctr">
-                      <a:solidFill>
-                        <a:srgbClr val="DDDDDD"/>
-                      </a:solidFill>
-                      <a:prstDash val="solid"/>
-                      <a:round/>
-                      <a:headEnd type="none" w="med" len="med"/>
-                      <a:tailEnd type="none" w="med" len="med"/>
-                    </a:lnL>
-                    <a:lnR w="6350" cap="flat" cmpd="sng" algn="ctr">
-                      <a:solidFill>
-                        <a:srgbClr val="DDDDDD"/>
-                      </a:solidFill>
-                      <a:prstDash val="solid"/>
-                      <a:round/>
-                      <a:headEnd type="none" w="med" len="med"/>
-                      <a:tailEnd type="none" w="med" len="med"/>
-                    </a:lnR>
-                    <a:lnT w="6350" cap="flat" cmpd="sng" algn="ctr">
-                      <a:solidFill>
-                        <a:srgbClr val="DDDDDD"/>
-                      </a:solidFill>
-                      <a:prstDash val="solid"/>
-                      <a:round/>
-                      <a:headEnd type="none" w="med" len="med"/>
-                      <a:tailEnd type="none" w="med" len="med"/>
-                    </a:lnT>
-                    <a:lnB w="6350" cap="flat" cmpd="sng" algn="ctr">
-                      <a:solidFill>
-                        <a:srgbClr val="DDDDDD"/>
-                      </a:solidFill>
-                      <a:prstDash val="solid"/>
-                      <a:round/>
-                      <a:headEnd type="none" w="med" len="med"/>
-                      <a:tailEnd type="none" w="med" len="med"/>
-                    </a:lnB>
-                  </a:tcPr>
-                </a:tc>
-                <a:tc>
-                  <a:txBody>
-                    <a:bodyPr/>
-                    <a:lstStyle/>
-                    <a:p>
-                      <a:pPr indent="0" marL="0">
-                        <a:buNone/>
-                      </a:pPr>
-                      <a:r>
-                        <a:rPr lang="en-US" sz="1200" dirty="0">
-                          <a:solidFill>
-                            <a:srgbClr val="000000"/>
-                          </a:solidFill>
-                          <a:latin typeface="Calibri" pitchFamily="34" charset="0"/>
-                          <a:ea typeface="Calibri" pitchFamily="34" charset="-122"/>
-                          <a:cs typeface="Calibri" pitchFamily="34" charset="-120"/>
-                        </a:rPr>
-                        <a:t>Complete</a:t>
-                      </a:r>
-                      <a:endParaRPr lang="en-US" sz="1200" dirty="0">
-                        <a:latin typeface="Calibri" charset="0"/>
-                        <a:ea typeface="Calibri" charset="0"/>
-                        <a:cs typeface="Calibri" charset="0"/>
-                      </a:endParaRPr>
-                    </a:p>
-                  </a:txBody>
-                  <a:tcPr marL="91440" marR="91440" marT="45720" marB="45720" anchor="t">
-                    <a:lnL w="6350" cap="flat" cmpd="sng" algn="ctr">
-                      <a:solidFill>
-                        <a:srgbClr val="DDDDDD"/>
-                      </a:solidFill>
-                      <a:prstDash val="solid"/>
-                      <a:round/>
-                      <a:headEnd type="none" w="med" len="med"/>
-                      <a:tailEnd type="none" w="med" len="med"/>
-                    </a:lnL>
-                    <a:lnR w="6350" cap="flat" cmpd="sng" algn="ctr">
-                      <a:solidFill>
-                        <a:srgbClr val="DDDDDD"/>
-                      </a:solidFill>
-                      <a:prstDash val="solid"/>
-                      <a:round/>
-                      <a:headEnd type="none" w="med" len="med"/>
-                      <a:tailEnd type="none" w="med" len="med"/>
-                    </a:lnR>
-                    <a:lnT w="6350" cap="flat" cmpd="sng" algn="ctr">
-                      <a:solidFill>
-                        <a:srgbClr val="DDDDDD"/>
-                      </a:solidFill>
-                      <a:prstDash val="solid"/>
-                      <a:round/>
-                      <a:headEnd type="none" w="med" len="med"/>
-                      <a:tailEnd type="none" w="med" len="med"/>
-                    </a:lnT>
-                    <a:lnB w="6350" cap="flat" cmpd="sng" algn="ctr">
-                      <a:solidFill>
-                        <a:srgbClr val="DDDDDD"/>
-                      </a:solidFill>
-                      <a:prstDash val="solid"/>
-                      <a:round/>
-                      <a:headEnd type="none" w="med" len="med"/>
-                      <a:tailEnd type="none" w="med" len="med"/>
-                    </a:lnB>
-                  </a:tcPr>
-                </a:tc>
-              </a:tr>
-            </a:tbl>
-          </a:graphicData>
-        </a:graphic>
-      </p:graphicFrame>
     </p:spTree>
   </p:cSld>
   <p:clrMapOvr>

</xml_diff>